<commit_message>
Recover takeover revision races and tolerate bounded audio jitter
</commit_message>
<xml_diff>
--- a/artifacts/submission/nursebridge-pitch.pptx
+++ b/artifacts/submission/nursebridge-pitch.pptx
@@ -2,19 +2,19 @@
 <file path=ppt/presentation.xml><?xml version="1.0" encoding="utf-8"?>
 <p:presentation xmlns:p="http://schemas.openxmlformats.org/presentationml/2006/main">
   <p:sldMasterIdLst>
-    <p:sldMasterId xmlns:r="http://schemas.openxmlformats.org/officeDocument/2006/relationships" id="2147483648" r:id="Re4a026c9b5f44060"/>
+    <p:sldMasterId xmlns:r="http://schemas.openxmlformats.org/officeDocument/2006/relationships" id="2147483648" r:id="Rfce1c330fe3641a4"/>
   </p:sldMasterIdLst>
   <p:notesMasterIdLst>
-    <p:notesMasterId xmlns:r="http://schemas.openxmlformats.org/officeDocument/2006/relationships" r:id="Rc7abea43fba7419a"/>
+    <p:notesMasterId xmlns:r="http://schemas.openxmlformats.org/officeDocument/2006/relationships" r:id="Rfbd02945e086426e"/>
   </p:notesMasterIdLst>
   <p:sldIdLst>
-    <p:sldId xmlns:r="http://schemas.openxmlformats.org/officeDocument/2006/relationships" id="256" r:id="R3c162fe9341d4112"/>
-    <p:sldId xmlns:r="http://schemas.openxmlformats.org/officeDocument/2006/relationships" id="257" r:id="R36226edd10be42ed"/>
-    <p:sldId xmlns:r="http://schemas.openxmlformats.org/officeDocument/2006/relationships" id="258" r:id="R8d279debdca8466f"/>
-    <p:sldId xmlns:r="http://schemas.openxmlformats.org/officeDocument/2006/relationships" id="259" r:id="Rf2b2d6078f984160"/>
-    <p:sldId xmlns:r="http://schemas.openxmlformats.org/officeDocument/2006/relationships" id="260" r:id="Rfa0eea354ea14259"/>
-    <p:sldId xmlns:r="http://schemas.openxmlformats.org/officeDocument/2006/relationships" id="261" r:id="R28947825e44347b1"/>
-    <p:sldId xmlns:r="http://schemas.openxmlformats.org/officeDocument/2006/relationships" id="262" r:id="R8879f19cf6c24f91"/>
+    <p:sldId xmlns:r="http://schemas.openxmlformats.org/officeDocument/2006/relationships" id="256" r:id="R29f9bbbf9fba4119"/>
+    <p:sldId xmlns:r="http://schemas.openxmlformats.org/officeDocument/2006/relationships" id="257" r:id="Rb2ac8769db514734"/>
+    <p:sldId xmlns:r="http://schemas.openxmlformats.org/officeDocument/2006/relationships" id="258" r:id="R38e95445642e43d0"/>
+    <p:sldId xmlns:r="http://schemas.openxmlformats.org/officeDocument/2006/relationships" id="259" r:id="R450db29f892344bf"/>
+    <p:sldId xmlns:r="http://schemas.openxmlformats.org/officeDocument/2006/relationships" id="260" r:id="R4f9139bd43f84c8b"/>
+    <p:sldId xmlns:r="http://schemas.openxmlformats.org/officeDocument/2006/relationships" id="261" r:id="R15220834cc444cff"/>
+    <p:sldId xmlns:r="http://schemas.openxmlformats.org/officeDocument/2006/relationships" id="262" r:id="Rd6f0b287da824c56"/>
   </p:sldIdLst>
   <p:sldSz cx="12192000" cy="6858000"/>
   <p:notesSz cx="6858000" cy="9144000"/>
@@ -828,7 +828,7 @@
           </a:p>
           <a:p xmlns:a="http://schemas.openxmlformats.org/drawingml/2006/main">
             <a:r>
-              <a:t>Sources: docs/test-results.md and docs/evidence/local-live-voice-2026-09-29.json. Regression results: 146 unit, 164 Workers, 19 tooling, 27 browser, with one live-provider test skipped in that regression run. Separate 29 Sep local live test passed with recorded microphones: one finalized caller turn, one evidence-linked fact, an agent response after caller speech, non-silent human playback in both receiving worklets, and zero stale agent samples after takeover. These are individual local observations, not reliability or latency guarantees. Provider API logical deletion is not proof of physical erasure or backup expiry. Public live activation still requires recording-control and device acceptance.</a:t>
+              <a:t>Sources: docs/test-results.md and docs/evidence/local-live-voice-2026-09-29.json. Regression results: 165 unit, 173 Workers, 19 tooling, 29 browser, with one live-provider test skipped in that regression run. Separate 29 Sep local live test passed with recorded microphones: one finalized caller turn, one evidence-linked fact, an agent response after caller speech, non-silent human playback in both receiving worklets, and zero stale agent samples after takeover. That provider check predates the latest polish fixes. These are individual local observations, not reliability or latency guarantees. Provider API logical deletion is not proof of physical erasure or backup expiry. Public live activation still requires recording-control and device acceptance.</a:t>
             </a:r>
           </a:p>
         </p:txBody>
@@ -971,7 +971,7 @@
   </p:cSld>
   <p:clrMap bg1="lt1" tx1="dk1" bg2="lt2" tx2="dk2" accent1="accent1" accent2="accent2" accent3="accent3" accent4="accent4" accent5="accent5" accent6="accent6" hlink="hlink" folHlink="folHlink"/>
   <p:sldLayoutIdLst>
-    <p:sldLayoutId xmlns:r="http://schemas.openxmlformats.org/officeDocument/2006/relationships" id="2147483649" r:id="Re76e849b5f67479f"/>
+    <p:sldLayoutId xmlns:r="http://schemas.openxmlformats.org/officeDocument/2006/relationships" id="2147483649" r:id="R4884ece9c66e41e1"/>
   </p:sldLayoutIdLst>
   <p:txStyles>
     <p:titleStyle>
@@ -2043,7 +2043,7 @@
           <p:nvPr/>
         </p:nvPicPr>
         <p:blipFill>
-          <a:blip xmlns:r="http://schemas.openxmlformats.org/officeDocument/2006/relationships" xmlns:a="http://schemas.openxmlformats.org/drawingml/2006/main" r:embed="Rea6da53880324d46"/>
+          <a:blip xmlns:r="http://schemas.openxmlformats.org/officeDocument/2006/relationships" xmlns:a="http://schemas.openxmlformats.org/drawingml/2006/main" r:embed="Rf036f4b473284eed"/>
           <a:srcRect xmlns:a="http://schemas.openxmlformats.org/drawingml/2006/main" l="21736" t="18687" r="36528" b="32179"/>
           <a:stretch xmlns:a="http://schemas.openxmlformats.org/drawingml/2006/main">
             <a:fillRect l="0" t="0" r="0" b="0"/>
@@ -2967,7 +2967,7 @@
           <p:nvPr/>
         </p:nvPicPr>
         <p:blipFill>
-          <a:blip xmlns:r="http://schemas.openxmlformats.org/officeDocument/2006/relationships" xmlns:a="http://schemas.openxmlformats.org/drawingml/2006/main" r:embed="R885d0cc94f0a45cf"/>
+          <a:blip xmlns:r="http://schemas.openxmlformats.org/officeDocument/2006/relationships" xmlns:a="http://schemas.openxmlformats.org/drawingml/2006/main" r:embed="R54e5674bd7594cda"/>
           <a:srcRect xmlns:a="http://schemas.openxmlformats.org/drawingml/2006/main" l="25972" t="22783" r="25278" b="55953"/>
           <a:stretch xmlns:a="http://schemas.openxmlformats.org/drawingml/2006/main">
             <a:fillRect l="0" t="0" r="0" b="0"/>
@@ -3311,7 +3311,7 @@
           <p:nvPr/>
         </p:nvPicPr>
         <p:blipFill>
-          <a:blip xmlns:r="http://schemas.openxmlformats.org/officeDocument/2006/relationships" xmlns:a="http://schemas.openxmlformats.org/drawingml/2006/main" r:embed="R7eebc672ca734617"/>
+          <a:blip xmlns:r="http://schemas.openxmlformats.org/officeDocument/2006/relationships" xmlns:a="http://schemas.openxmlformats.org/drawingml/2006/main" r:embed="R93abdc8bf74a4d32"/>
           <a:srcRect xmlns:a="http://schemas.openxmlformats.org/drawingml/2006/main" l="26111" t="17209" r="2083" b="50800"/>
           <a:stretch xmlns:a="http://schemas.openxmlformats.org/drawingml/2006/main">
             <a:fillRect l="0" t="0" r="0" b="0"/>
@@ -4424,7 +4424,7 @@
                 <a:ea typeface="Helvetica Neue"/>
                 <a:cs typeface="Helvetica Neue"/>
               </a:rPr>
-              <a:t>146</a:t>
+              <a:t>165</a:t>
             </a:r>
           </a:p>
         </p:txBody>
@@ -4540,7 +4540,7 @@
                 <a:ea typeface="Helvetica Neue"/>
                 <a:cs typeface="Helvetica Neue"/>
               </a:rPr>
-              <a:t>164</a:t>
+              <a:t>173</a:t>
             </a:r>
           </a:p>
         </p:txBody>
@@ -4656,7 +4656,7 @@
                 <a:ea typeface="Helvetica Neue"/>
                 <a:cs typeface="Helvetica Neue"/>
               </a:rPr>
-              <a:t>27</a:t>
+              <a:t>29</a:t>
             </a:r>
           </a:p>
         </p:txBody>

</xml_diff>

<commit_message>
Allow audio arrival phase jitter and retain safe failure state
</commit_message>
<xml_diff>
--- a/artifacts/submission/nursebridge-pitch.pptx
+++ b/artifacts/submission/nursebridge-pitch.pptx
@@ -2,19 +2,19 @@
 <file path=ppt/presentation.xml><?xml version="1.0" encoding="utf-8"?>
 <p:presentation xmlns:p="http://schemas.openxmlformats.org/presentationml/2006/main">
   <p:sldMasterIdLst>
-    <p:sldMasterId xmlns:r="http://schemas.openxmlformats.org/officeDocument/2006/relationships" id="2147483648" r:id="Rfce1c330fe3641a4"/>
+    <p:sldMasterId xmlns:r="http://schemas.openxmlformats.org/officeDocument/2006/relationships" id="2147483648" r:id="R31fce3e7f27542cc"/>
   </p:sldMasterIdLst>
   <p:notesMasterIdLst>
-    <p:notesMasterId xmlns:r="http://schemas.openxmlformats.org/officeDocument/2006/relationships" r:id="Rfbd02945e086426e"/>
+    <p:notesMasterId xmlns:r="http://schemas.openxmlformats.org/officeDocument/2006/relationships" r:id="Rffe8085c519a4599"/>
   </p:notesMasterIdLst>
   <p:sldIdLst>
-    <p:sldId xmlns:r="http://schemas.openxmlformats.org/officeDocument/2006/relationships" id="256" r:id="R29f9bbbf9fba4119"/>
-    <p:sldId xmlns:r="http://schemas.openxmlformats.org/officeDocument/2006/relationships" id="257" r:id="Rb2ac8769db514734"/>
-    <p:sldId xmlns:r="http://schemas.openxmlformats.org/officeDocument/2006/relationships" id="258" r:id="R38e95445642e43d0"/>
-    <p:sldId xmlns:r="http://schemas.openxmlformats.org/officeDocument/2006/relationships" id="259" r:id="R450db29f892344bf"/>
-    <p:sldId xmlns:r="http://schemas.openxmlformats.org/officeDocument/2006/relationships" id="260" r:id="R4f9139bd43f84c8b"/>
-    <p:sldId xmlns:r="http://schemas.openxmlformats.org/officeDocument/2006/relationships" id="261" r:id="R15220834cc444cff"/>
-    <p:sldId xmlns:r="http://schemas.openxmlformats.org/officeDocument/2006/relationships" id="262" r:id="Rd6f0b287da824c56"/>
+    <p:sldId xmlns:r="http://schemas.openxmlformats.org/officeDocument/2006/relationships" id="256" r:id="Rf8fb3ba49c6241d1"/>
+    <p:sldId xmlns:r="http://schemas.openxmlformats.org/officeDocument/2006/relationships" id="257" r:id="Rf37ee3fd7c2a4094"/>
+    <p:sldId xmlns:r="http://schemas.openxmlformats.org/officeDocument/2006/relationships" id="258" r:id="R7bd69f5a20b847c6"/>
+    <p:sldId xmlns:r="http://schemas.openxmlformats.org/officeDocument/2006/relationships" id="259" r:id="Rd97090186d1243bd"/>
+    <p:sldId xmlns:r="http://schemas.openxmlformats.org/officeDocument/2006/relationships" id="260" r:id="R44c2817c2b764b56"/>
+    <p:sldId xmlns:r="http://schemas.openxmlformats.org/officeDocument/2006/relationships" id="261" r:id="R94a78279e8194844"/>
+    <p:sldId xmlns:r="http://schemas.openxmlformats.org/officeDocument/2006/relationships" id="262" r:id="Rcc48f79d024641a3"/>
   </p:sldIdLst>
   <p:sldSz cx="12192000" cy="6858000"/>
   <p:notesSz cx="6858000" cy="9144000"/>
@@ -828,7 +828,7 @@
           </a:p>
           <a:p xmlns:a="http://schemas.openxmlformats.org/drawingml/2006/main">
             <a:r>
-              <a:t>Sources: docs/test-results.md and docs/evidence/local-live-voice-2026-09-29.json. Regression results: 165 unit, 173 Workers, 19 tooling, 29 browser, with one live-provider test skipped in that regression run. Separate 29 Sep local live test passed with recorded microphones: one finalized caller turn, one evidence-linked fact, an agent response after caller speech, non-silent human playback in both receiving worklets, and zero stale agent samples after takeover. That provider check predates the latest polish fixes. These are individual local observations, not reliability or latency guarantees. Provider API logical deletion is not proof of physical erasure or backup expiry. Public live activation still requires recording-control and device acceptance.</a:t>
+              <a:t>Sources: docs/test-results.md and docs/evidence/local-live-voice-2026-09-29.json. Regression results: 168 unit, 177 Workers, 19 tooling, 29 browser, with one live-provider test skipped in that regression run. Separate 29 Sep local live test passed with recorded microphones: one finalized caller turn, one evidence-linked fact, an agent response after caller speech, non-silent human playback in both receiving worklets, and zero stale agent samples after takeover. That provider check predates the latest polish fixes. These are individual local observations, not reliability or latency guarantees. Provider API logical deletion is not proof of physical erasure or backup expiry. Public live activation still requires recording-control and device acceptance.</a:t>
             </a:r>
           </a:p>
         </p:txBody>
@@ -971,7 +971,7 @@
   </p:cSld>
   <p:clrMap bg1="lt1" tx1="dk1" bg2="lt2" tx2="dk2" accent1="accent1" accent2="accent2" accent3="accent3" accent4="accent4" accent5="accent5" accent6="accent6" hlink="hlink" folHlink="folHlink"/>
   <p:sldLayoutIdLst>
-    <p:sldLayoutId xmlns:r="http://schemas.openxmlformats.org/officeDocument/2006/relationships" id="2147483649" r:id="R4884ece9c66e41e1"/>
+    <p:sldLayoutId xmlns:r="http://schemas.openxmlformats.org/officeDocument/2006/relationships" id="2147483649" r:id="R069b6831cb864332"/>
   </p:sldLayoutIdLst>
   <p:txStyles>
     <p:titleStyle>
@@ -2043,7 +2043,7 @@
           <p:nvPr/>
         </p:nvPicPr>
         <p:blipFill>
-          <a:blip xmlns:r="http://schemas.openxmlformats.org/officeDocument/2006/relationships" xmlns:a="http://schemas.openxmlformats.org/drawingml/2006/main" r:embed="Rf036f4b473284eed"/>
+          <a:blip xmlns:r="http://schemas.openxmlformats.org/officeDocument/2006/relationships" xmlns:a="http://schemas.openxmlformats.org/drawingml/2006/main" r:embed="R1cbe7c382c56491b"/>
           <a:srcRect xmlns:a="http://schemas.openxmlformats.org/drawingml/2006/main" l="21736" t="18687" r="36528" b="32179"/>
           <a:stretch xmlns:a="http://schemas.openxmlformats.org/drawingml/2006/main">
             <a:fillRect l="0" t="0" r="0" b="0"/>
@@ -2967,7 +2967,7 @@
           <p:nvPr/>
         </p:nvPicPr>
         <p:blipFill>
-          <a:blip xmlns:r="http://schemas.openxmlformats.org/officeDocument/2006/relationships" xmlns:a="http://schemas.openxmlformats.org/drawingml/2006/main" r:embed="R54e5674bd7594cda"/>
+          <a:blip xmlns:r="http://schemas.openxmlformats.org/officeDocument/2006/relationships" xmlns:a="http://schemas.openxmlformats.org/drawingml/2006/main" r:embed="R8bed5aab11f94d33"/>
           <a:srcRect xmlns:a="http://schemas.openxmlformats.org/drawingml/2006/main" l="25972" t="22783" r="25278" b="55953"/>
           <a:stretch xmlns:a="http://schemas.openxmlformats.org/drawingml/2006/main">
             <a:fillRect l="0" t="0" r="0" b="0"/>
@@ -3311,7 +3311,7 @@
           <p:nvPr/>
         </p:nvPicPr>
         <p:blipFill>
-          <a:blip xmlns:r="http://schemas.openxmlformats.org/officeDocument/2006/relationships" xmlns:a="http://schemas.openxmlformats.org/drawingml/2006/main" r:embed="R93abdc8bf74a4d32"/>
+          <a:blip xmlns:r="http://schemas.openxmlformats.org/officeDocument/2006/relationships" xmlns:a="http://schemas.openxmlformats.org/drawingml/2006/main" r:embed="R8eeff3123d9641a4"/>
           <a:srcRect xmlns:a="http://schemas.openxmlformats.org/drawingml/2006/main" l="26111" t="17209" r="2083" b="50800"/>
           <a:stretch xmlns:a="http://schemas.openxmlformats.org/drawingml/2006/main">
             <a:fillRect l="0" t="0" r="0" b="0"/>
@@ -4424,7 +4424,7 @@
                 <a:ea typeface="Helvetica Neue"/>
                 <a:cs typeface="Helvetica Neue"/>
               </a:rPr>
-              <a:t>165</a:t>
+              <a:t>168</a:t>
             </a:r>
           </a:p>
         </p:txBody>
@@ -4540,7 +4540,7 @@
                 <a:ea typeface="Helvetica Neue"/>
                 <a:cs typeface="Helvetica Neue"/>
               </a:rPr>
-              <a:t>173</a:t>
+              <a:t>177</a:t>
             </a:r>
           </a:p>
         </p:txBody>

</xml_diff>

<commit_message>
Record polished live-provider acceptance and refresh submission evidence
</commit_message>
<xml_diff>
--- a/artifacts/submission/nursebridge-pitch.pptx
+++ b/artifacts/submission/nursebridge-pitch.pptx
@@ -2,19 +2,19 @@
 <file path=ppt/presentation.xml><?xml version="1.0" encoding="utf-8"?>
 <p:presentation xmlns:p="http://schemas.openxmlformats.org/presentationml/2006/main">
   <p:sldMasterIdLst>
-    <p:sldMasterId xmlns:r="http://schemas.openxmlformats.org/officeDocument/2006/relationships" id="2147483648" r:id="R31fce3e7f27542cc"/>
+    <p:sldMasterId xmlns:r="http://schemas.openxmlformats.org/officeDocument/2006/relationships" id="2147483648" r:id="R215b033b0e854009"/>
   </p:sldMasterIdLst>
   <p:notesMasterIdLst>
-    <p:notesMasterId xmlns:r="http://schemas.openxmlformats.org/officeDocument/2006/relationships" r:id="Rffe8085c519a4599"/>
+    <p:notesMasterId xmlns:r="http://schemas.openxmlformats.org/officeDocument/2006/relationships" r:id="R97b4dd31e2b942e7"/>
   </p:notesMasterIdLst>
   <p:sldIdLst>
-    <p:sldId xmlns:r="http://schemas.openxmlformats.org/officeDocument/2006/relationships" id="256" r:id="Rf8fb3ba49c6241d1"/>
-    <p:sldId xmlns:r="http://schemas.openxmlformats.org/officeDocument/2006/relationships" id="257" r:id="Rf37ee3fd7c2a4094"/>
-    <p:sldId xmlns:r="http://schemas.openxmlformats.org/officeDocument/2006/relationships" id="258" r:id="R7bd69f5a20b847c6"/>
-    <p:sldId xmlns:r="http://schemas.openxmlformats.org/officeDocument/2006/relationships" id="259" r:id="Rd97090186d1243bd"/>
-    <p:sldId xmlns:r="http://schemas.openxmlformats.org/officeDocument/2006/relationships" id="260" r:id="R44c2817c2b764b56"/>
-    <p:sldId xmlns:r="http://schemas.openxmlformats.org/officeDocument/2006/relationships" id="261" r:id="R94a78279e8194844"/>
-    <p:sldId xmlns:r="http://schemas.openxmlformats.org/officeDocument/2006/relationships" id="262" r:id="Rcc48f79d024641a3"/>
+    <p:sldId xmlns:r="http://schemas.openxmlformats.org/officeDocument/2006/relationships" id="256" r:id="R398fdfd112374393"/>
+    <p:sldId xmlns:r="http://schemas.openxmlformats.org/officeDocument/2006/relationships" id="257" r:id="Re37a5e8c58d345bb"/>
+    <p:sldId xmlns:r="http://schemas.openxmlformats.org/officeDocument/2006/relationships" id="258" r:id="Redb9b8f75bf64110"/>
+    <p:sldId xmlns:r="http://schemas.openxmlformats.org/officeDocument/2006/relationships" id="259" r:id="Ra27aecb7bc224279"/>
+    <p:sldId xmlns:r="http://schemas.openxmlformats.org/officeDocument/2006/relationships" id="260" r:id="Re95a83ea9185498e"/>
+    <p:sldId xmlns:r="http://schemas.openxmlformats.org/officeDocument/2006/relationships" id="261" r:id="Re8d33a99152148b1"/>
+    <p:sldId xmlns:r="http://schemas.openxmlformats.org/officeDocument/2006/relationships" id="262" r:id="Rd818130f3c874c77"/>
   </p:sldIdLst>
   <p:sldSz cx="12192000" cy="6858000"/>
   <p:notesSz cx="6858000" cy="9144000"/>
@@ -828,7 +828,7 @@
           </a:p>
           <a:p xmlns:a="http://schemas.openxmlformats.org/drawingml/2006/main">
             <a:r>
-              <a:t>Sources: docs/test-results.md and docs/evidence/local-live-voice-2026-09-29.json. Regression results: 168 unit, 177 Workers, 19 tooling, 29 browser, with one live-provider test skipped in that regression run. Separate 29 Sep local live test passed with recorded microphones: one finalized caller turn, one evidence-linked fact, an agent response after caller speech, non-silent human playback in both receiving worklets, and zero stale agent samples after takeover. That provider check predates the latest polish fixes. These are individual local observations, not reliability or latency guarantees. Provider API logical deletion is not proof of physical erasure or backup expiry. Public live activation still requires recording-control and device acceptance.</a:t>
+              <a:t>Sources: docs/test-results.md and docs/evidence/polished-live-voice-2026-09-29.json. Regression results: 168 unit, 177 Workers, 19 tooling, 29 browser, with one live-provider test skipped in that regression run. Separate opted-in local AssemblyAI/Nebius acceptance passed on the polished source revision 743cce2 on 29 Sep 2026 in 30.8 seconds, using recorded microphones. It produced one finalized caller turn, one evidence-linked fact, three assistant turns, non-silent human playback in both receiving worklets, zero stale agent samples, and zero dropped frames. The case finished CLOSED and deleted, with no pending provider deletions or unresolved provider connections. These are individual local observations, not reliability or latency guarantees. Provider API logical deletion is not proof of physical erasure or backup expiry. Public live activation still requires recording-control and physical-device acceptance. No hosted deployment or real telephone-network acceptance is claimed.</a:t>
             </a:r>
           </a:p>
         </p:txBody>
@@ -971,7 +971,7 @@
   </p:cSld>
   <p:clrMap bg1="lt1" tx1="dk1" bg2="lt2" tx2="dk2" accent1="accent1" accent2="accent2" accent3="accent3" accent4="accent4" accent5="accent5" accent6="accent6" hlink="hlink" folHlink="folHlink"/>
   <p:sldLayoutIdLst>
-    <p:sldLayoutId xmlns:r="http://schemas.openxmlformats.org/officeDocument/2006/relationships" id="2147483649" r:id="R069b6831cb864332"/>
+    <p:sldLayoutId xmlns:r="http://schemas.openxmlformats.org/officeDocument/2006/relationships" id="2147483649" r:id="R3d8266d3f3c44d6f"/>
   </p:sldLayoutIdLst>
   <p:txStyles>
     <p:titleStyle>
@@ -2043,7 +2043,7 @@
           <p:nvPr/>
         </p:nvPicPr>
         <p:blipFill>
-          <a:blip xmlns:r="http://schemas.openxmlformats.org/officeDocument/2006/relationships" xmlns:a="http://schemas.openxmlformats.org/drawingml/2006/main" r:embed="R1cbe7c382c56491b"/>
+          <a:blip xmlns:r="http://schemas.openxmlformats.org/officeDocument/2006/relationships" xmlns:a="http://schemas.openxmlformats.org/drawingml/2006/main" r:embed="Re4801f1d3ac54dfd"/>
           <a:srcRect xmlns:a="http://schemas.openxmlformats.org/drawingml/2006/main" l="21736" t="18687" r="36528" b="32179"/>
           <a:stretch xmlns:a="http://schemas.openxmlformats.org/drawingml/2006/main">
             <a:fillRect l="0" t="0" r="0" b="0"/>
@@ -2967,7 +2967,7 @@
           <p:nvPr/>
         </p:nvPicPr>
         <p:blipFill>
-          <a:blip xmlns:r="http://schemas.openxmlformats.org/officeDocument/2006/relationships" xmlns:a="http://schemas.openxmlformats.org/drawingml/2006/main" r:embed="R8bed5aab11f94d33"/>
+          <a:blip xmlns:r="http://schemas.openxmlformats.org/officeDocument/2006/relationships" xmlns:a="http://schemas.openxmlformats.org/drawingml/2006/main" r:embed="R2bd2da7530bc4511"/>
           <a:srcRect xmlns:a="http://schemas.openxmlformats.org/drawingml/2006/main" l="25972" t="22783" r="25278" b="55953"/>
           <a:stretch xmlns:a="http://schemas.openxmlformats.org/drawingml/2006/main">
             <a:fillRect l="0" t="0" r="0" b="0"/>
@@ -3311,7 +3311,7 @@
           <p:nvPr/>
         </p:nvPicPr>
         <p:blipFill>
-          <a:blip xmlns:r="http://schemas.openxmlformats.org/officeDocument/2006/relationships" xmlns:a="http://schemas.openxmlformats.org/drawingml/2006/main" r:embed="R8eeff3123d9641a4"/>
+          <a:blip xmlns:r="http://schemas.openxmlformats.org/officeDocument/2006/relationships" xmlns:a="http://schemas.openxmlformats.org/drawingml/2006/main" r:embed="Rb1c644857b084ac5"/>
           <a:srcRect xmlns:a="http://schemas.openxmlformats.org/drawingml/2006/main" l="26111" t="17209" r="2083" b="50800"/>
           <a:stretch xmlns:a="http://schemas.openxmlformats.org/drawingml/2006/main">
             <a:fillRect l="0" t="0" r="0" b="0"/>

</xml_diff>